<commit_message>
Asl rangli logotiplar qo'yildi, palitra yashil-ko'kka moslandi
Co-Authored-By: Claude Opus 5.5 <noreply@anthropic.com>
Claude-Session: https://claude.ai/code/session_01TmKjqMXxLdu749iNSP1Yhn
</commit_message>
<xml_diff>
--- a/saylov_oq_fon.pptx
+++ b/saylov_oq_fon.pptx
@@ -3123,11 +3123,11 @@
             <a:avLst/>
           </a:prstGeom>
           <a:solidFill>
-            <a:srgbClr val="C9DCF2"/>
+            <a:srgbClr val="CFE3D6"/>
           </a:solidFill>
           <a:ln>
             <a:solidFill>
-              <a:srgbClr val="C9DCF2"/>
+              <a:srgbClr val="CFE3D6"/>
             </a:solidFill>
           </a:ln>
         </p:spPr>
@@ -3180,7 +3180,7 @@
             <a:r>
               <a:rPr sz="800" b="1">
                 <a:solidFill>
-                  <a:srgbClr val="4A5D78"/>
+                  <a:srgbClr val="4B5E57"/>
                 </a:solidFill>
                 <a:latin typeface="Aptos"/>
               </a:rPr>
@@ -3215,7 +3215,7 @@
             <a:r>
               <a:rPr sz="1700" b="1">
                 <a:solidFill>
-                  <a:srgbClr val="4A5D78"/>
+                  <a:srgbClr val="4B5E57"/>
                 </a:solidFill>
                 <a:latin typeface="Aptos"/>
               </a:rPr>
@@ -3251,7 +3251,7 @@
             <a:r>
               <a:rPr sz="3800" b="1">
                 <a:solidFill>
-                  <a:srgbClr val="0F2F6B"/>
+                  <a:srgbClr val="1B4134"/>
                 </a:solidFill>
                 <a:latin typeface="Aptos"/>
               </a:rPr>
@@ -3287,7 +3287,7 @@
             <a:r>
               <a:rPr sz="1600" b="1">
                 <a:solidFill>
-                  <a:srgbClr val="0072BC"/>
+                  <a:srgbClr val="0A6CD6"/>
                 </a:solidFill>
                 <a:latin typeface="Aptos"/>
               </a:rPr>
@@ -3322,7 +3322,7 @@
             <a:r>
               <a:rPr sz="2500" b="1">
                 <a:solidFill>
-                  <a:srgbClr val="0F2F6B"/>
+                  <a:srgbClr val="1B4134"/>
                 </a:solidFill>
                 <a:latin typeface="Aptos"/>
               </a:rPr>
@@ -3357,7 +3357,7 @@
             <a:r>
               <a:rPr sz="1400" b="0">
                 <a:solidFill>
-                  <a:srgbClr val="4A5D78"/>
+                  <a:srgbClr val="4B5E57"/>
                 </a:solidFill>
                 <a:latin typeface="Aptos"/>
               </a:rPr>
@@ -3474,11 +3474,11 @@
             <a:avLst/>
           </a:prstGeom>
           <a:solidFill>
-            <a:srgbClr val="C9DCF2"/>
+            <a:srgbClr val="CFE3D6"/>
           </a:solidFill>
           <a:ln>
             <a:solidFill>
-              <a:srgbClr val="C9DCF2"/>
+              <a:srgbClr val="CFE3D6"/>
             </a:solidFill>
           </a:ln>
         </p:spPr>
@@ -3531,7 +3531,7 @@
             <a:r>
               <a:rPr sz="800" b="1">
                 <a:solidFill>
-                  <a:srgbClr val="4A5D78"/>
+                  <a:srgbClr val="4B5E57"/>
                 </a:solidFill>
                 <a:latin typeface="Aptos"/>
               </a:rPr>
@@ -3566,7 +3566,7 @@
             <a:r>
               <a:rPr sz="2800" b="1">
                 <a:solidFill>
-                  <a:srgbClr val="0F2F6B"/>
+                  <a:srgbClr val="1B4134"/>
                 </a:solidFill>
                 <a:latin typeface="Aptos"/>
               </a:rPr>
@@ -3590,11 +3590,11 @@
             <a:avLst/>
           </a:prstGeom>
           <a:solidFill>
-            <a:srgbClr val="0072BC"/>
+            <a:srgbClr val="0A6CD6"/>
           </a:solidFill>
           <a:ln>
             <a:solidFill>
-              <a:srgbClr val="0072BC"/>
+              <a:srgbClr val="0A6CD6"/>
             </a:solidFill>
           </a:ln>
         </p:spPr>
@@ -3647,7 +3647,7 @@
             <a:r>
               <a:rPr sz="1300" b="0">
                 <a:solidFill>
-                  <a:srgbClr val="4A5D78"/>
+                  <a:srgbClr val="4B5E57"/>
                 </a:solidFill>
                 <a:latin typeface="Aptos"/>
               </a:rPr>
@@ -3671,11 +3671,11 @@
             <a:avLst/>
           </a:prstGeom>
           <a:solidFill>
-            <a:srgbClr val="EEF3FA"/>
+            <a:srgbClr val="EFF5F1"/>
           </a:solidFill>
           <a:ln>
             <a:solidFill>
-              <a:srgbClr val="EEF3FA"/>
+              <a:srgbClr val="EFF5F1"/>
             </a:solidFill>
           </a:ln>
         </p:spPr>
@@ -3728,7 +3728,7 @@
             <a:r>
               <a:rPr sz="1300" b="1">
                 <a:solidFill>
-                  <a:srgbClr val="0072BC"/>
+                  <a:srgbClr val="0A6CD6"/>
                 </a:solidFill>
                 <a:latin typeface="Aptos"/>
               </a:rPr>
@@ -3763,7 +3763,7 @@
             <a:r>
               <a:rPr sz="1600" b="1">
                 <a:solidFill>
-                  <a:srgbClr val="0F2F6B"/>
+                  <a:srgbClr val="1B4134"/>
                 </a:solidFill>
                 <a:latin typeface="Aptos"/>
               </a:rPr>
@@ -3798,7 +3798,7 @@
             <a:r>
               <a:rPr sz="1200" b="0">
                 <a:solidFill>
-                  <a:srgbClr val="4A5D78"/>
+                  <a:srgbClr val="4B5E57"/>
                 </a:solidFill>
                 <a:latin typeface="Aptos"/>
               </a:rPr>
@@ -3822,11 +3822,11 @@
             <a:avLst/>
           </a:prstGeom>
           <a:solidFill>
-            <a:srgbClr val="EEF3FA"/>
+            <a:srgbClr val="EFF5F1"/>
           </a:solidFill>
           <a:ln>
             <a:solidFill>
-              <a:srgbClr val="EEF3FA"/>
+              <a:srgbClr val="EFF5F1"/>
             </a:solidFill>
           </a:ln>
         </p:spPr>
@@ -3879,7 +3879,7 @@
             <a:r>
               <a:rPr sz="1300" b="1">
                 <a:solidFill>
-                  <a:srgbClr val="0072BC"/>
+                  <a:srgbClr val="0A6CD6"/>
                 </a:solidFill>
                 <a:latin typeface="Aptos"/>
               </a:rPr>
@@ -3914,7 +3914,7 @@
             <a:r>
               <a:rPr sz="1600" b="1">
                 <a:solidFill>
-                  <a:srgbClr val="0F2F6B"/>
+                  <a:srgbClr val="1B4134"/>
                 </a:solidFill>
                 <a:latin typeface="Aptos"/>
               </a:rPr>
@@ -3949,7 +3949,7 @@
             <a:r>
               <a:rPr sz="1200" b="0">
                 <a:solidFill>
-                  <a:srgbClr val="4A5D78"/>
+                  <a:srgbClr val="4B5E57"/>
                 </a:solidFill>
                 <a:latin typeface="Aptos"/>
               </a:rPr>
@@ -3973,11 +3973,11 @@
             <a:avLst/>
           </a:prstGeom>
           <a:solidFill>
-            <a:srgbClr val="EEF3FA"/>
+            <a:srgbClr val="EFF5F1"/>
           </a:solidFill>
           <a:ln>
             <a:solidFill>
-              <a:srgbClr val="EEF3FA"/>
+              <a:srgbClr val="EFF5F1"/>
             </a:solidFill>
           </a:ln>
         </p:spPr>
@@ -4030,7 +4030,7 @@
             <a:r>
               <a:rPr sz="1300" b="1">
                 <a:solidFill>
-                  <a:srgbClr val="0072BC"/>
+                  <a:srgbClr val="0A6CD6"/>
                 </a:solidFill>
                 <a:latin typeface="Aptos"/>
               </a:rPr>
@@ -4065,7 +4065,7 @@
             <a:r>
               <a:rPr sz="1600" b="1">
                 <a:solidFill>
-                  <a:srgbClr val="0F2F6B"/>
+                  <a:srgbClr val="1B4134"/>
                 </a:solidFill>
                 <a:latin typeface="Aptos"/>
               </a:rPr>
@@ -4100,7 +4100,7 @@
             <a:r>
               <a:rPr sz="1200" b="0">
                 <a:solidFill>
-                  <a:srgbClr val="4A5D78"/>
+                  <a:srgbClr val="4B5E57"/>
                 </a:solidFill>
                 <a:latin typeface="Aptos"/>
               </a:rPr>
@@ -4124,11 +4124,11 @@
             <a:avLst/>
           </a:prstGeom>
           <a:solidFill>
-            <a:srgbClr val="EEF3FA"/>
+            <a:srgbClr val="EFF5F1"/>
           </a:solidFill>
           <a:ln>
             <a:solidFill>
-              <a:srgbClr val="EEF3FA"/>
+              <a:srgbClr val="EFF5F1"/>
             </a:solidFill>
           </a:ln>
         </p:spPr>
@@ -4181,7 +4181,7 @@
             <a:r>
               <a:rPr sz="1300" b="1">
                 <a:solidFill>
-                  <a:srgbClr val="0072BC"/>
+                  <a:srgbClr val="0A6CD6"/>
                 </a:solidFill>
                 <a:latin typeface="Aptos"/>
               </a:rPr>
@@ -4216,7 +4216,7 @@
             <a:r>
               <a:rPr sz="1600" b="1">
                 <a:solidFill>
-                  <a:srgbClr val="0F2F6B"/>
+                  <a:srgbClr val="1B4134"/>
                 </a:solidFill>
                 <a:latin typeface="Aptos"/>
               </a:rPr>
@@ -4251,7 +4251,7 @@
             <a:r>
               <a:rPr sz="1200" b="0">
                 <a:solidFill>
-                  <a:srgbClr val="4A5D78"/>
+                  <a:srgbClr val="4B5E57"/>
                 </a:solidFill>
                 <a:latin typeface="Aptos"/>
               </a:rPr>
@@ -4368,11 +4368,11 @@
             <a:avLst/>
           </a:prstGeom>
           <a:solidFill>
-            <a:srgbClr val="C9DCF2"/>
+            <a:srgbClr val="CFE3D6"/>
           </a:solidFill>
           <a:ln>
             <a:solidFill>
-              <a:srgbClr val="C9DCF2"/>
+              <a:srgbClr val="CFE3D6"/>
             </a:solidFill>
           </a:ln>
         </p:spPr>
@@ -4425,7 +4425,7 @@
             <a:r>
               <a:rPr sz="800" b="1">
                 <a:solidFill>
-                  <a:srgbClr val="4A5D78"/>
+                  <a:srgbClr val="4B5E57"/>
                 </a:solidFill>
                 <a:latin typeface="Aptos"/>
               </a:rPr>
@@ -4460,7 +4460,7 @@
             <a:r>
               <a:rPr sz="3000" b="1">
                 <a:solidFill>
-                  <a:srgbClr val="0F2F6B"/>
+                  <a:srgbClr val="1B4134"/>
                 </a:solidFill>
                 <a:latin typeface="Aptos"/>
               </a:rPr>
@@ -4495,7 +4495,7 @@
             <a:r>
               <a:rPr sz="1700" b="1">
                 <a:solidFill>
-                  <a:srgbClr val="0072BC"/>
+                  <a:srgbClr val="0A6CD6"/>
                 </a:solidFill>
                 <a:latin typeface="Aptos"/>
               </a:rPr>
@@ -4530,7 +4530,7 @@
             <a:r>
               <a:rPr sz="1400" b="1">
                 <a:solidFill>
-                  <a:srgbClr val="4A5D78"/>
+                  <a:srgbClr val="4B5E57"/>
                 </a:solidFill>
                 <a:latin typeface="Aptos"/>
               </a:rPr>
@@ -4554,11 +4554,11 @@
             <a:avLst/>
           </a:prstGeom>
           <a:solidFill>
-            <a:srgbClr val="0072BC"/>
+            <a:srgbClr val="0A6CD6"/>
           </a:solidFill>
           <a:ln>
             <a:solidFill>
-              <a:srgbClr val="0072BC"/>
+              <a:srgbClr val="0A6CD6"/>
             </a:solidFill>
           </a:ln>
         </p:spPr>
@@ -4611,7 +4611,7 @@
             <a:r>
               <a:rPr sz="2500" b="1">
                 <a:solidFill>
-                  <a:srgbClr val="0F2F6B"/>
+                  <a:srgbClr val="1B4134"/>
                 </a:solidFill>
                 <a:latin typeface="Aptos"/>
               </a:rPr>
@@ -4646,7 +4646,7 @@
             <a:r>
               <a:rPr sz="1600" b="1">
                 <a:solidFill>
-                  <a:srgbClr val="4A5D78"/>
+                  <a:srgbClr val="4B5E57"/>
                 </a:solidFill>
                 <a:latin typeface="Aptos"/>
               </a:rPr>
@@ -4681,7 +4681,7 @@
             <a:r>
               <a:rPr sz="2500" b="1">
                 <a:solidFill>
-                  <a:srgbClr val="0072BC"/>
+                  <a:srgbClr val="0A6CD6"/>
                 </a:solidFill>
                 <a:latin typeface="Aptos"/>
               </a:rPr>
@@ -4798,11 +4798,11 @@
             <a:avLst/>
           </a:prstGeom>
           <a:solidFill>
-            <a:srgbClr val="C9DCF2"/>
+            <a:srgbClr val="CFE3D6"/>
           </a:solidFill>
           <a:ln>
             <a:solidFill>
-              <a:srgbClr val="C9DCF2"/>
+              <a:srgbClr val="CFE3D6"/>
             </a:solidFill>
           </a:ln>
         </p:spPr>
@@ -4855,7 +4855,7 @@
             <a:r>
               <a:rPr sz="800" b="1">
                 <a:solidFill>
-                  <a:srgbClr val="4A5D78"/>
+                  <a:srgbClr val="4B5E57"/>
                 </a:solidFill>
                 <a:latin typeface="Aptos"/>
               </a:rPr>
@@ -4890,7 +4890,7 @@
             <a:r>
               <a:rPr sz="2800" b="1">
                 <a:solidFill>
-                  <a:srgbClr val="0F2F6B"/>
+                  <a:srgbClr val="1B4134"/>
                 </a:solidFill>
                 <a:latin typeface="Aptos"/>
               </a:rPr>
@@ -4914,11 +4914,11 @@
             <a:avLst/>
           </a:prstGeom>
           <a:solidFill>
-            <a:srgbClr val="0072BC"/>
+            <a:srgbClr val="0A6CD6"/>
           </a:solidFill>
           <a:ln>
             <a:solidFill>
-              <a:srgbClr val="0072BC"/>
+              <a:srgbClr val="0A6CD6"/>
             </a:solidFill>
           </a:ln>
         </p:spPr>
@@ -4971,7 +4971,7 @@
             <a:r>
               <a:rPr sz="1300" b="0">
                 <a:solidFill>
-                  <a:srgbClr val="4A5D78"/>
+                  <a:srgbClr val="4B5E57"/>
                 </a:solidFill>
                 <a:latin typeface="Aptos"/>
               </a:rPr>
@@ -4995,11 +4995,11 @@
             <a:avLst/>
           </a:prstGeom>
           <a:solidFill>
-            <a:srgbClr val="EEF3FA"/>
+            <a:srgbClr val="EFF5F1"/>
           </a:solidFill>
           <a:ln>
             <a:solidFill>
-              <a:srgbClr val="EEF3FA"/>
+              <a:srgbClr val="EFF5F1"/>
             </a:solidFill>
           </a:ln>
         </p:spPr>
@@ -5052,7 +5052,7 @@
             <a:r>
               <a:rPr sz="1100" b="1">
                 <a:solidFill>
-                  <a:srgbClr val="4A5D78"/>
+                  <a:srgbClr val="4B5E57"/>
                 </a:solidFill>
                 <a:latin typeface="Aptos"/>
               </a:rPr>
@@ -5087,7 +5087,7 @@
             <a:r>
               <a:rPr sz="1400" b="0">
                 <a:solidFill>
-                  <a:srgbClr val="0F2F6B"/>
+                  <a:srgbClr val="1B4134"/>
                 </a:solidFill>
                 <a:latin typeface="Aptos"/>
               </a:rPr>
@@ -5122,7 +5122,7 @@
             <a:r>
               <a:rPr sz="1100" b="1">
                 <a:solidFill>
-                  <a:srgbClr val="4A5D78"/>
+                  <a:srgbClr val="4B5E57"/>
                 </a:solidFill>
                 <a:latin typeface="Aptos"/>
               </a:rPr>
@@ -5157,7 +5157,7 @@
             <a:r>
               <a:rPr sz="1400" b="0">
                 <a:solidFill>
-                  <a:srgbClr val="0F2F6B"/>
+                  <a:srgbClr val="1B4134"/>
                 </a:solidFill>
                 <a:latin typeface="Aptos"/>
               </a:rPr>
@@ -5192,7 +5192,7 @@
             <a:r>
               <a:rPr sz="1100" b="1">
                 <a:solidFill>
-                  <a:srgbClr val="4A5D78"/>
+                  <a:srgbClr val="4B5E57"/>
                 </a:solidFill>
                 <a:latin typeface="Aptos"/>
               </a:rPr>
@@ -5227,7 +5227,7 @@
             <a:r>
               <a:rPr sz="1400" b="0">
                 <a:solidFill>
-                  <a:srgbClr val="0F2F6B"/>
+                  <a:srgbClr val="1B4134"/>
                 </a:solidFill>
                 <a:latin typeface="Aptos"/>
               </a:rPr>
@@ -5262,7 +5262,7 @@
             <a:r>
               <a:rPr sz="1100" b="1">
                 <a:solidFill>
-                  <a:srgbClr val="4A5D78"/>
+                  <a:srgbClr val="4B5E57"/>
                 </a:solidFill>
                 <a:latin typeface="Aptos"/>
               </a:rPr>
@@ -5297,7 +5297,7 @@
             <a:r>
               <a:rPr sz="1400" b="0">
                 <a:solidFill>
-                  <a:srgbClr val="0F2F6B"/>
+                  <a:srgbClr val="1B4134"/>
                 </a:solidFill>
                 <a:latin typeface="Aptos"/>
               </a:rPr>
@@ -5332,7 +5332,7 @@
             <a:r>
               <a:rPr sz="1100" b="1">
                 <a:solidFill>
-                  <a:srgbClr val="4A5D78"/>
+                  <a:srgbClr val="4B5E57"/>
                 </a:solidFill>
                 <a:latin typeface="Aptos"/>
               </a:rPr>
@@ -5367,7 +5367,7 @@
             <a:r>
               <a:rPr sz="1400" b="0">
                 <a:solidFill>
-                  <a:srgbClr val="0F2F6B"/>
+                  <a:srgbClr val="1B4134"/>
                 </a:solidFill>
                 <a:latin typeface="Aptos"/>
               </a:rPr>
@@ -5402,7 +5402,7 @@
             <a:r>
               <a:rPr sz="1100" b="1">
                 <a:solidFill>
-                  <a:srgbClr val="4A5D78"/>
+                  <a:srgbClr val="4B5E57"/>
                 </a:solidFill>
                 <a:latin typeface="Aptos"/>
               </a:rPr>
@@ -5437,7 +5437,7 @@
             <a:r>
               <a:rPr sz="1400" b="0">
                 <a:solidFill>
-                  <a:srgbClr val="0F2F6B"/>
+                  <a:srgbClr val="1B4134"/>
                 </a:solidFill>
                 <a:latin typeface="Aptos"/>
               </a:rPr>
@@ -5472,7 +5472,7 @@
             <a:r>
               <a:rPr sz="1100" b="1">
                 <a:solidFill>
-                  <a:srgbClr val="4A5D78"/>
+                  <a:srgbClr val="4B5E57"/>
                 </a:solidFill>
                 <a:latin typeface="Aptos"/>
               </a:rPr>
@@ -5507,7 +5507,7 @@
             <a:r>
               <a:rPr sz="1400" b="0">
                 <a:solidFill>
-                  <a:srgbClr val="0F2F6B"/>
+                  <a:srgbClr val="1B4134"/>
                 </a:solidFill>
                 <a:latin typeface="Aptos"/>
               </a:rPr>
@@ -5531,11 +5531,11 @@
             <a:avLst/>
           </a:prstGeom>
           <a:solidFill>
-            <a:srgbClr val="E1EDF9"/>
+            <a:srgbClr val="EAF3FC"/>
           </a:solidFill>
           <a:ln>
             <a:solidFill>
-              <a:srgbClr val="E1EDF9"/>
+              <a:srgbClr val="EAF3FC"/>
             </a:solidFill>
           </a:ln>
         </p:spPr>
@@ -5588,7 +5588,7 @@
             <a:r>
               <a:rPr sz="1300" b="1">
                 <a:solidFill>
-                  <a:srgbClr val="0072BC"/>
+                  <a:srgbClr val="0A6CD6"/>
                 </a:solidFill>
                 <a:latin typeface="Aptos"/>
               </a:rPr>
@@ -5623,7 +5623,7 @@
             <a:r>
               <a:rPr sz="2300" b="1">
                 <a:solidFill>
-                  <a:srgbClr val="0F2F6B"/>
+                  <a:srgbClr val="1B4134"/>
                 </a:solidFill>
                 <a:latin typeface="Aptos"/>
               </a:rPr>
@@ -5661,7 +5661,7 @@
             <a:r>
               <a:rPr sz="1200" b="0">
                 <a:solidFill>
-                  <a:srgbClr val="4A5D78"/>
+                  <a:srgbClr val="4B5E57"/>
                 </a:solidFill>
                 <a:latin typeface="Aptos"/>
               </a:rPr>
@@ -5778,11 +5778,11 @@
             <a:avLst/>
           </a:prstGeom>
           <a:solidFill>
-            <a:srgbClr val="C9DCF2"/>
+            <a:srgbClr val="CFE3D6"/>
           </a:solidFill>
           <a:ln>
             <a:solidFill>
-              <a:srgbClr val="C9DCF2"/>
+              <a:srgbClr val="CFE3D6"/>
             </a:solidFill>
           </a:ln>
         </p:spPr>
@@ -5835,7 +5835,7 @@
             <a:r>
               <a:rPr sz="800" b="1">
                 <a:solidFill>
-                  <a:srgbClr val="4A5D78"/>
+                  <a:srgbClr val="4B5E57"/>
                 </a:solidFill>
                 <a:latin typeface="Aptos"/>
               </a:rPr>
@@ -5870,7 +5870,7 @@
             <a:r>
               <a:rPr sz="2800" b="1">
                 <a:solidFill>
-                  <a:srgbClr val="0F2F6B"/>
+                  <a:srgbClr val="1B4134"/>
                 </a:solidFill>
                 <a:latin typeface="Aptos"/>
               </a:rPr>
@@ -5894,11 +5894,11 @@
             <a:avLst/>
           </a:prstGeom>
           <a:solidFill>
-            <a:srgbClr val="0072BC"/>
+            <a:srgbClr val="0A6CD6"/>
           </a:solidFill>
           <a:ln>
             <a:solidFill>
-              <a:srgbClr val="0072BC"/>
+              <a:srgbClr val="0A6CD6"/>
             </a:solidFill>
           </a:ln>
         </p:spPr>
@@ -5951,7 +5951,7 @@
             <a:r>
               <a:rPr sz="1300" b="0">
                 <a:solidFill>
-                  <a:srgbClr val="4A5D78"/>
+                  <a:srgbClr val="4B5E57"/>
                 </a:solidFill>
                 <a:latin typeface="Aptos"/>
               </a:rPr>
@@ -5999,11 +5999,11 @@
             <a:avLst/>
           </a:prstGeom>
           <a:solidFill>
-            <a:srgbClr val="EEF3FA"/>
+            <a:srgbClr val="EFF5F1"/>
           </a:solidFill>
           <a:ln>
             <a:solidFill>
-              <a:srgbClr val="EEF3FA"/>
+              <a:srgbClr val="EFF5F1"/>
             </a:solidFill>
           </a:ln>
         </p:spPr>
@@ -6045,11 +6045,11 @@
             <a:avLst/>
           </a:prstGeom>
           <a:solidFill>
-            <a:srgbClr val="0072BC"/>
+            <a:srgbClr val="0A6CD6"/>
           </a:solidFill>
           <a:ln>
             <a:solidFill>
-              <a:srgbClr val="0072BC"/>
+              <a:srgbClr val="0A6CD6"/>
             </a:solidFill>
           </a:ln>
         </p:spPr>
@@ -6102,7 +6102,7 @@
             <a:r>
               <a:rPr sz="1300" b="1">
                 <a:solidFill>
-                  <a:srgbClr val="0F2F6B"/>
+                  <a:srgbClr val="1B4134"/>
                 </a:solidFill>
                 <a:latin typeface="Aptos"/>
               </a:rPr>
@@ -6137,7 +6137,7 @@
             <a:r>
               <a:rPr sz="1100" b="0">
                 <a:solidFill>
-                  <a:srgbClr val="4A5D78"/>
+                  <a:srgbClr val="4B5E57"/>
                 </a:solidFill>
                 <a:latin typeface="Aptos"/>
               </a:rPr>
@@ -6161,11 +6161,11 @@
             <a:avLst/>
           </a:prstGeom>
           <a:solidFill>
-            <a:srgbClr val="0072BC"/>
+            <a:srgbClr val="0A6CD6"/>
           </a:solidFill>
           <a:ln>
             <a:solidFill>
-              <a:srgbClr val="0072BC"/>
+              <a:srgbClr val="0A6CD6"/>
             </a:solidFill>
           </a:ln>
         </p:spPr>
@@ -6218,7 +6218,7 @@
             <a:r>
               <a:rPr sz="1300" b="1">
                 <a:solidFill>
-                  <a:srgbClr val="0F2F6B"/>
+                  <a:srgbClr val="1B4134"/>
                 </a:solidFill>
                 <a:latin typeface="Aptos"/>
               </a:rPr>
@@ -6253,7 +6253,7 @@
             <a:r>
               <a:rPr sz="1100" b="0">
                 <a:solidFill>
-                  <a:srgbClr val="4A5D78"/>
+                  <a:srgbClr val="4B5E57"/>
                 </a:solidFill>
                 <a:latin typeface="Aptos"/>
               </a:rPr>
@@ -6277,11 +6277,11 @@
             <a:avLst/>
           </a:prstGeom>
           <a:solidFill>
-            <a:srgbClr val="0072BC"/>
+            <a:srgbClr val="0A6CD6"/>
           </a:solidFill>
           <a:ln>
             <a:solidFill>
-              <a:srgbClr val="0072BC"/>
+              <a:srgbClr val="0A6CD6"/>
             </a:solidFill>
           </a:ln>
         </p:spPr>
@@ -6334,7 +6334,7 @@
             <a:r>
               <a:rPr sz="1300" b="1">
                 <a:solidFill>
-                  <a:srgbClr val="0F2F6B"/>
+                  <a:srgbClr val="1B4134"/>
                 </a:solidFill>
                 <a:latin typeface="Aptos"/>
               </a:rPr>
@@ -6369,7 +6369,7 @@
             <a:r>
               <a:rPr sz="1100" b="0">
                 <a:solidFill>
-                  <a:srgbClr val="4A5D78"/>
+                  <a:srgbClr val="4B5E57"/>
                 </a:solidFill>
                 <a:latin typeface="Aptos"/>
               </a:rPr>
@@ -6393,11 +6393,11 @@
             <a:avLst/>
           </a:prstGeom>
           <a:solidFill>
-            <a:srgbClr val="0072BC"/>
+            <a:srgbClr val="0A6CD6"/>
           </a:solidFill>
           <a:ln>
             <a:solidFill>
-              <a:srgbClr val="0072BC"/>
+              <a:srgbClr val="0A6CD6"/>
             </a:solidFill>
           </a:ln>
         </p:spPr>
@@ -6450,7 +6450,7 @@
             <a:r>
               <a:rPr sz="1300" b="1">
                 <a:solidFill>
-                  <a:srgbClr val="0F2F6B"/>
+                  <a:srgbClr val="1B4134"/>
                 </a:solidFill>
                 <a:latin typeface="Aptos"/>
               </a:rPr>
@@ -6485,7 +6485,7 @@
             <a:r>
               <a:rPr sz="1100" b="0">
                 <a:solidFill>
-                  <a:srgbClr val="4A5D78"/>
+                  <a:srgbClr val="4B5E57"/>
                 </a:solidFill>
                 <a:latin typeface="Aptos"/>
               </a:rPr>
@@ -6509,11 +6509,11 @@
             <a:avLst/>
           </a:prstGeom>
           <a:solidFill>
-            <a:srgbClr val="0072BC"/>
+            <a:srgbClr val="0A6CD6"/>
           </a:solidFill>
           <a:ln>
             <a:solidFill>
-              <a:srgbClr val="0072BC"/>
+              <a:srgbClr val="0A6CD6"/>
             </a:solidFill>
           </a:ln>
         </p:spPr>
@@ -6566,7 +6566,7 @@
             <a:r>
               <a:rPr sz="1300" b="1">
                 <a:solidFill>
-                  <a:srgbClr val="0F2F6B"/>
+                  <a:srgbClr val="1B4134"/>
                 </a:solidFill>
                 <a:latin typeface="Aptos"/>
               </a:rPr>
@@ -6601,7 +6601,7 @@
             <a:r>
               <a:rPr sz="1100" b="0">
                 <a:solidFill>
-                  <a:srgbClr val="4A5D78"/>
+                  <a:srgbClr val="4B5E57"/>
                 </a:solidFill>
                 <a:latin typeface="Aptos"/>
               </a:rPr>
@@ -6718,11 +6718,11 @@
             <a:avLst/>
           </a:prstGeom>
           <a:solidFill>
-            <a:srgbClr val="C9DCF2"/>
+            <a:srgbClr val="CFE3D6"/>
           </a:solidFill>
           <a:ln>
             <a:solidFill>
-              <a:srgbClr val="C9DCF2"/>
+              <a:srgbClr val="CFE3D6"/>
             </a:solidFill>
           </a:ln>
         </p:spPr>
@@ -6775,7 +6775,7 @@
             <a:r>
               <a:rPr sz="800" b="1">
                 <a:solidFill>
-                  <a:srgbClr val="4A5D78"/>
+                  <a:srgbClr val="4B5E57"/>
                 </a:solidFill>
                 <a:latin typeface="Aptos"/>
               </a:rPr>
@@ -6810,7 +6810,7 @@
             <a:r>
               <a:rPr sz="2800" b="1">
                 <a:solidFill>
-                  <a:srgbClr val="0F2F6B"/>
+                  <a:srgbClr val="1B4134"/>
                 </a:solidFill>
                 <a:latin typeface="Aptos"/>
               </a:rPr>
@@ -6834,11 +6834,11 @@
             <a:avLst/>
           </a:prstGeom>
           <a:solidFill>
-            <a:srgbClr val="0072BC"/>
+            <a:srgbClr val="0A6CD6"/>
           </a:solidFill>
           <a:ln>
             <a:solidFill>
-              <a:srgbClr val="0072BC"/>
+              <a:srgbClr val="0A6CD6"/>
             </a:solidFill>
           </a:ln>
         </p:spPr>
@@ -6891,7 +6891,7 @@
             <a:r>
               <a:rPr sz="1300" b="0">
                 <a:solidFill>
-                  <a:srgbClr val="4A5D78"/>
+                  <a:srgbClr val="4B5E57"/>
                 </a:solidFill>
                 <a:latin typeface="Aptos"/>
               </a:rPr>
@@ -6915,11 +6915,11 @@
             <a:avLst/>
           </a:prstGeom>
           <a:solidFill>
-            <a:srgbClr val="EEF3FA"/>
+            <a:srgbClr val="EFF5F1"/>
           </a:solidFill>
           <a:ln>
             <a:solidFill>
-              <a:srgbClr val="EEF3FA"/>
+              <a:srgbClr val="EFF5F1"/>
             </a:solidFill>
           </a:ln>
         </p:spPr>
@@ -6972,7 +6972,7 @@
             <a:r>
               <a:rPr sz="1300" b="1">
                 <a:solidFill>
-                  <a:srgbClr val="0072BC"/>
+                  <a:srgbClr val="0A6CD6"/>
                 </a:solidFill>
                 <a:latin typeface="Aptos"/>
               </a:rPr>
@@ -7007,7 +7007,7 @@
             <a:r>
               <a:rPr sz="2000" b="1">
                 <a:solidFill>
-                  <a:srgbClr val="0F2F6B"/>
+                  <a:srgbClr val="1B4134"/>
                 </a:solidFill>
                 <a:latin typeface="Aptos"/>
               </a:rPr>
@@ -7042,7 +7042,7 @@
             <a:r>
               <a:rPr sz="1300" b="0">
                 <a:solidFill>
-                  <a:srgbClr val="4A5D78"/>
+                  <a:srgbClr val="4B5E57"/>
                 </a:solidFill>
                 <a:latin typeface="Aptos"/>
               </a:rPr>
@@ -7066,11 +7066,11 @@
             <a:avLst/>
           </a:prstGeom>
           <a:solidFill>
-            <a:srgbClr val="EEF3FA"/>
+            <a:srgbClr val="EFF5F1"/>
           </a:solidFill>
           <a:ln>
             <a:solidFill>
-              <a:srgbClr val="EEF3FA"/>
+              <a:srgbClr val="EFF5F1"/>
             </a:solidFill>
           </a:ln>
         </p:spPr>
@@ -7123,7 +7123,7 @@
             <a:r>
               <a:rPr sz="1300" b="1">
                 <a:solidFill>
-                  <a:srgbClr val="0072BC"/>
+                  <a:srgbClr val="0A6CD6"/>
                 </a:solidFill>
                 <a:latin typeface="Aptos"/>
               </a:rPr>
@@ -7158,7 +7158,7 @@
             <a:r>
               <a:rPr sz="2000" b="1">
                 <a:solidFill>
-                  <a:srgbClr val="0F2F6B"/>
+                  <a:srgbClr val="1B4134"/>
                 </a:solidFill>
                 <a:latin typeface="Aptos"/>
               </a:rPr>
@@ -7193,7 +7193,7 @@
             <a:r>
               <a:rPr sz="1300" b="0">
                 <a:solidFill>
-                  <a:srgbClr val="4A5D78"/>
+                  <a:srgbClr val="4B5E57"/>
                 </a:solidFill>
                 <a:latin typeface="Aptos"/>
               </a:rPr>
@@ -7217,11 +7217,11 @@
             <a:avLst/>
           </a:prstGeom>
           <a:solidFill>
-            <a:srgbClr val="EEF3FA"/>
+            <a:srgbClr val="EFF5F1"/>
           </a:solidFill>
           <a:ln>
             <a:solidFill>
-              <a:srgbClr val="EEF3FA"/>
+              <a:srgbClr val="EFF5F1"/>
             </a:solidFill>
           </a:ln>
         </p:spPr>
@@ -7274,7 +7274,7 @@
             <a:r>
               <a:rPr sz="1300" b="1">
                 <a:solidFill>
-                  <a:srgbClr val="0072BC"/>
+                  <a:srgbClr val="0A6CD6"/>
                 </a:solidFill>
                 <a:latin typeface="Aptos"/>
               </a:rPr>
@@ -7309,7 +7309,7 @@
             <a:r>
               <a:rPr sz="2000" b="1">
                 <a:solidFill>
-                  <a:srgbClr val="0F2F6B"/>
+                  <a:srgbClr val="1B4134"/>
                 </a:solidFill>
                 <a:latin typeface="Aptos"/>
               </a:rPr>
@@ -7344,7 +7344,7 @@
             <a:r>
               <a:rPr sz="1300" b="0">
                 <a:solidFill>
-                  <a:srgbClr val="4A5D78"/>
+                  <a:srgbClr val="4B5E57"/>
                 </a:solidFill>
                 <a:latin typeface="Aptos"/>
               </a:rPr>
@@ -7461,11 +7461,11 @@
             <a:avLst/>
           </a:prstGeom>
           <a:solidFill>
-            <a:srgbClr val="C9DCF2"/>
+            <a:srgbClr val="CFE3D6"/>
           </a:solidFill>
           <a:ln>
             <a:solidFill>
-              <a:srgbClr val="C9DCF2"/>
+              <a:srgbClr val="CFE3D6"/>
             </a:solidFill>
           </a:ln>
         </p:spPr>
@@ -7518,7 +7518,7 @@
             <a:r>
               <a:rPr sz="800" b="1">
                 <a:solidFill>
-                  <a:srgbClr val="4A5D78"/>
+                  <a:srgbClr val="4B5E57"/>
                 </a:solidFill>
                 <a:latin typeface="Aptos"/>
               </a:rPr>
@@ -7553,7 +7553,7 @@
             <a:r>
               <a:rPr sz="2800" b="1">
                 <a:solidFill>
-                  <a:srgbClr val="0F2F6B"/>
+                  <a:srgbClr val="1B4134"/>
                 </a:solidFill>
                 <a:latin typeface="Aptos"/>
               </a:rPr>
@@ -7577,11 +7577,11 @@
             <a:avLst/>
           </a:prstGeom>
           <a:solidFill>
-            <a:srgbClr val="0072BC"/>
+            <a:srgbClr val="0A6CD6"/>
           </a:solidFill>
           <a:ln>
             <a:solidFill>
-              <a:srgbClr val="0072BC"/>
+              <a:srgbClr val="0A6CD6"/>
             </a:solidFill>
           </a:ln>
         </p:spPr>
@@ -7634,7 +7634,7 @@
             <a:r>
               <a:rPr sz="1300" b="0">
                 <a:solidFill>
-                  <a:srgbClr val="4A5D78"/>
+                  <a:srgbClr val="4B5E57"/>
                 </a:solidFill>
                 <a:latin typeface="Aptos"/>
               </a:rPr>
@@ -7658,11 +7658,11 @@
             <a:avLst/>
           </a:prstGeom>
           <a:solidFill>
-            <a:srgbClr val="EEF3FA"/>
+            <a:srgbClr val="EFF5F1"/>
           </a:solidFill>
           <a:ln>
             <a:solidFill>
-              <a:srgbClr val="EEF3FA"/>
+              <a:srgbClr val="EFF5F1"/>
             </a:solidFill>
           </a:ln>
         </p:spPr>
@@ -7715,7 +7715,7 @@
             <a:r>
               <a:rPr sz="1200" b="1">
                 <a:solidFill>
-                  <a:srgbClr val="0072BC"/>
+                  <a:srgbClr val="0A6CD6"/>
                 </a:solidFill>
                 <a:latin typeface="Aptos"/>
               </a:rPr>
@@ -7750,7 +7750,7 @@
             <a:r>
               <a:rPr sz="1700" b="1">
                 <a:solidFill>
-                  <a:srgbClr val="0F2F6B"/>
+                  <a:srgbClr val="1B4134"/>
                 </a:solidFill>
                 <a:latin typeface="Aptos"/>
               </a:rPr>
@@ -7785,7 +7785,7 @@
             <a:r>
               <a:rPr sz="1100" b="0">
                 <a:solidFill>
-                  <a:srgbClr val="4A5D78"/>
+                  <a:srgbClr val="4B5E57"/>
                 </a:solidFill>
                 <a:latin typeface="Aptos"/>
               </a:rPr>
@@ -7809,11 +7809,11 @@
             <a:avLst/>
           </a:prstGeom>
           <a:solidFill>
-            <a:srgbClr val="EEF3FA"/>
+            <a:srgbClr val="EFF5F1"/>
           </a:solidFill>
           <a:ln>
             <a:solidFill>
-              <a:srgbClr val="EEF3FA"/>
+              <a:srgbClr val="EFF5F1"/>
             </a:solidFill>
           </a:ln>
         </p:spPr>
@@ -7866,7 +7866,7 @@
             <a:r>
               <a:rPr sz="1200" b="1">
                 <a:solidFill>
-                  <a:srgbClr val="0072BC"/>
+                  <a:srgbClr val="0A6CD6"/>
                 </a:solidFill>
                 <a:latin typeface="Aptos"/>
               </a:rPr>
@@ -7901,7 +7901,7 @@
             <a:r>
               <a:rPr sz="1700" b="1">
                 <a:solidFill>
-                  <a:srgbClr val="0F2F6B"/>
+                  <a:srgbClr val="1B4134"/>
                 </a:solidFill>
                 <a:latin typeface="Aptos"/>
               </a:rPr>
@@ -7936,7 +7936,7 @@
             <a:r>
               <a:rPr sz="1100" b="0">
                 <a:solidFill>
-                  <a:srgbClr val="4A5D78"/>
+                  <a:srgbClr val="4B5E57"/>
                 </a:solidFill>
                 <a:latin typeface="Aptos"/>
               </a:rPr>
@@ -7960,11 +7960,11 @@
             <a:avLst/>
           </a:prstGeom>
           <a:solidFill>
-            <a:srgbClr val="EEF3FA"/>
+            <a:srgbClr val="EFF5F1"/>
           </a:solidFill>
           <a:ln>
             <a:solidFill>
-              <a:srgbClr val="EEF3FA"/>
+              <a:srgbClr val="EFF5F1"/>
             </a:solidFill>
           </a:ln>
         </p:spPr>
@@ -8017,7 +8017,7 @@
             <a:r>
               <a:rPr sz="1200" b="1">
                 <a:solidFill>
-                  <a:srgbClr val="0072BC"/>
+                  <a:srgbClr val="0A6CD6"/>
                 </a:solidFill>
                 <a:latin typeface="Aptos"/>
               </a:rPr>
@@ -8052,7 +8052,7 @@
             <a:r>
               <a:rPr sz="1700" b="1">
                 <a:solidFill>
-                  <a:srgbClr val="0F2F6B"/>
+                  <a:srgbClr val="1B4134"/>
                 </a:solidFill>
                 <a:latin typeface="Aptos"/>
               </a:rPr>
@@ -8087,7 +8087,7 @@
             <a:r>
               <a:rPr sz="1100" b="0">
                 <a:solidFill>
-                  <a:srgbClr val="4A5D78"/>
+                  <a:srgbClr val="4B5E57"/>
                 </a:solidFill>
                 <a:latin typeface="Aptos"/>
               </a:rPr>
@@ -8111,11 +8111,11 @@
             <a:avLst/>
           </a:prstGeom>
           <a:solidFill>
-            <a:srgbClr val="EEF3FA"/>
+            <a:srgbClr val="EFF5F1"/>
           </a:solidFill>
           <a:ln>
             <a:solidFill>
-              <a:srgbClr val="EEF3FA"/>
+              <a:srgbClr val="EFF5F1"/>
             </a:solidFill>
           </a:ln>
         </p:spPr>
@@ -8168,7 +8168,7 @@
             <a:r>
               <a:rPr sz="1200" b="1">
                 <a:solidFill>
-                  <a:srgbClr val="0072BC"/>
+                  <a:srgbClr val="0A6CD6"/>
                 </a:solidFill>
                 <a:latin typeface="Aptos"/>
               </a:rPr>
@@ -8203,7 +8203,7 @@
             <a:r>
               <a:rPr sz="1700" b="1">
                 <a:solidFill>
-                  <a:srgbClr val="0F2F6B"/>
+                  <a:srgbClr val="1B4134"/>
                 </a:solidFill>
                 <a:latin typeface="Aptos"/>
               </a:rPr>
@@ -8238,7 +8238,7 @@
             <a:r>
               <a:rPr sz="1100" b="0">
                 <a:solidFill>
-                  <a:srgbClr val="4A5D78"/>
+                  <a:srgbClr val="4B5E57"/>
                 </a:solidFill>
                 <a:latin typeface="Aptos"/>
               </a:rPr>
@@ -8355,11 +8355,11 @@
             <a:avLst/>
           </a:prstGeom>
           <a:solidFill>
-            <a:srgbClr val="C9DCF2"/>
+            <a:srgbClr val="CFE3D6"/>
           </a:solidFill>
           <a:ln>
             <a:solidFill>
-              <a:srgbClr val="C9DCF2"/>
+              <a:srgbClr val="CFE3D6"/>
             </a:solidFill>
           </a:ln>
         </p:spPr>
@@ -8412,7 +8412,7 @@
             <a:r>
               <a:rPr sz="800" b="1">
                 <a:solidFill>
-                  <a:srgbClr val="4A5D78"/>
+                  <a:srgbClr val="4B5E57"/>
                 </a:solidFill>
                 <a:latin typeface="Aptos"/>
               </a:rPr>
@@ -8447,7 +8447,7 @@
             <a:r>
               <a:rPr sz="2800" b="1">
                 <a:solidFill>
-                  <a:srgbClr val="0F2F6B"/>
+                  <a:srgbClr val="1B4134"/>
                 </a:solidFill>
                 <a:latin typeface="Aptos"/>
               </a:rPr>
@@ -8471,11 +8471,11 @@
             <a:avLst/>
           </a:prstGeom>
           <a:solidFill>
-            <a:srgbClr val="0072BC"/>
+            <a:srgbClr val="0A6CD6"/>
           </a:solidFill>
           <a:ln>
             <a:solidFill>
-              <a:srgbClr val="0072BC"/>
+              <a:srgbClr val="0A6CD6"/>
             </a:solidFill>
           </a:ln>
         </p:spPr>
@@ -8528,7 +8528,7 @@
             <a:r>
               <a:rPr sz="1300" b="0">
                 <a:solidFill>
-                  <a:srgbClr val="4A5D78"/>
+                  <a:srgbClr val="4B5E57"/>
                 </a:solidFill>
                 <a:latin typeface="Aptos"/>
               </a:rPr>
@@ -8552,11 +8552,11 @@
             <a:avLst/>
           </a:prstGeom>
           <a:solidFill>
-            <a:srgbClr val="E1EDF9"/>
+            <a:srgbClr val="EAF3FC"/>
           </a:solidFill>
           <a:ln>
             <a:solidFill>
-              <a:srgbClr val="E1EDF9"/>
+              <a:srgbClr val="EAF3FC"/>
             </a:solidFill>
           </a:ln>
         </p:spPr>
@@ -8609,7 +8609,7 @@
             <a:r>
               <a:rPr sz="1200" b="1">
                 <a:solidFill>
-                  <a:srgbClr val="0072BC"/>
+                  <a:srgbClr val="0A6CD6"/>
                 </a:solidFill>
                 <a:latin typeface="Aptos"/>
               </a:rPr>
@@ -8644,7 +8644,7 @@
             <a:r>
               <a:rPr sz="2200" b="1">
                 <a:solidFill>
-                  <a:srgbClr val="0F2F6B"/>
+                  <a:srgbClr val="1B4134"/>
                 </a:solidFill>
                 <a:latin typeface="Aptos"/>
               </a:rPr>
@@ -8669,11 +8669,11 @@
             <a:avLst/>
           </a:prstGeom>
           <a:solidFill>
-            <a:srgbClr val="EEF3FA"/>
+            <a:srgbClr val="EFF5F1"/>
           </a:solidFill>
           <a:ln>
             <a:solidFill>
-              <a:srgbClr val="EEF3FA"/>
+              <a:srgbClr val="EFF5F1"/>
             </a:solidFill>
           </a:ln>
         </p:spPr>
@@ -8726,7 +8726,7 @@
             <a:r>
               <a:rPr sz="1300" b="1">
                 <a:solidFill>
-                  <a:srgbClr val="0072BC"/>
+                  <a:srgbClr val="0A6CD6"/>
                 </a:solidFill>
                 <a:latin typeface="Aptos"/>
               </a:rPr>
@@ -8761,7 +8761,7 @@
             <a:r>
               <a:rPr sz="1100" b="0">
                 <a:solidFill>
-                  <a:srgbClr val="4A5D78"/>
+                  <a:srgbClr val="4B5E57"/>
                 </a:solidFill>
                 <a:latin typeface="Aptos"/>
               </a:rPr>
@@ -8785,11 +8785,11 @@
             <a:avLst/>
           </a:prstGeom>
           <a:solidFill>
-            <a:srgbClr val="EEF3FA"/>
+            <a:srgbClr val="EFF5F1"/>
           </a:solidFill>
           <a:ln>
             <a:solidFill>
-              <a:srgbClr val="EEF3FA"/>
+              <a:srgbClr val="EFF5F1"/>
             </a:solidFill>
           </a:ln>
         </p:spPr>
@@ -8842,7 +8842,7 @@
             <a:r>
               <a:rPr sz="1300" b="1">
                 <a:solidFill>
-                  <a:srgbClr val="0072BC"/>
+                  <a:srgbClr val="0A6CD6"/>
                 </a:solidFill>
                 <a:latin typeface="Aptos"/>
               </a:rPr>
@@ -8877,7 +8877,7 @@
             <a:r>
               <a:rPr sz="1100" b="0">
                 <a:solidFill>
-                  <a:srgbClr val="4A5D78"/>
+                  <a:srgbClr val="4B5E57"/>
                 </a:solidFill>
                 <a:latin typeface="Aptos"/>
               </a:rPr>
@@ -8901,11 +8901,11 @@
             <a:avLst/>
           </a:prstGeom>
           <a:solidFill>
-            <a:srgbClr val="EEF3FA"/>
+            <a:srgbClr val="EFF5F1"/>
           </a:solidFill>
           <a:ln>
             <a:solidFill>
-              <a:srgbClr val="EEF3FA"/>
+              <a:srgbClr val="EFF5F1"/>
             </a:solidFill>
           </a:ln>
         </p:spPr>
@@ -8958,7 +8958,7 @@
             <a:r>
               <a:rPr sz="1300" b="1">
                 <a:solidFill>
-                  <a:srgbClr val="0072BC"/>
+                  <a:srgbClr val="0A6CD6"/>
                 </a:solidFill>
                 <a:latin typeface="Aptos"/>
               </a:rPr>
@@ -8993,7 +8993,7 @@
             <a:r>
               <a:rPr sz="1100" b="0">
                 <a:solidFill>
-                  <a:srgbClr val="4A5D78"/>
+                  <a:srgbClr val="4B5E57"/>
                 </a:solidFill>
                 <a:latin typeface="Aptos"/>
               </a:rPr>
@@ -9110,11 +9110,11 @@
             <a:avLst/>
           </a:prstGeom>
           <a:solidFill>
-            <a:srgbClr val="C9DCF2"/>
+            <a:srgbClr val="CFE3D6"/>
           </a:solidFill>
           <a:ln>
             <a:solidFill>
-              <a:srgbClr val="C9DCF2"/>
+              <a:srgbClr val="CFE3D6"/>
             </a:solidFill>
           </a:ln>
         </p:spPr>
@@ -9167,7 +9167,7 @@
             <a:r>
               <a:rPr sz="800" b="1">
                 <a:solidFill>
-                  <a:srgbClr val="4A5D78"/>
+                  <a:srgbClr val="4B5E57"/>
                 </a:solidFill>
                 <a:latin typeface="Aptos"/>
               </a:rPr>
@@ -9202,7 +9202,7 @@
             <a:r>
               <a:rPr sz="2800" b="1">
                 <a:solidFill>
-                  <a:srgbClr val="0F2F6B"/>
+                  <a:srgbClr val="1B4134"/>
                 </a:solidFill>
                 <a:latin typeface="Aptos"/>
               </a:rPr>
@@ -9226,11 +9226,11 @@
             <a:avLst/>
           </a:prstGeom>
           <a:solidFill>
-            <a:srgbClr val="0072BC"/>
+            <a:srgbClr val="0A6CD6"/>
           </a:solidFill>
           <a:ln>
             <a:solidFill>
-              <a:srgbClr val="0072BC"/>
+              <a:srgbClr val="0A6CD6"/>
             </a:solidFill>
           </a:ln>
         </p:spPr>
@@ -9283,7 +9283,7 @@
             <a:r>
               <a:rPr sz="1300" b="0">
                 <a:solidFill>
-                  <a:srgbClr val="4A5D78"/>
+                  <a:srgbClr val="4B5E57"/>
                 </a:solidFill>
                 <a:latin typeface="Aptos"/>
               </a:rPr>
@@ -9307,11 +9307,11 @@
             <a:avLst/>
           </a:prstGeom>
           <a:solidFill>
-            <a:srgbClr val="EEF3FA"/>
+            <a:srgbClr val="EFF5F1"/>
           </a:solidFill>
           <a:ln>
             <a:solidFill>
-              <a:srgbClr val="EEF3FA"/>
+              <a:srgbClr val="EFF5F1"/>
             </a:solidFill>
           </a:ln>
         </p:spPr>
@@ -9364,7 +9364,7 @@
             <a:r>
               <a:rPr sz="1300" b="1">
                 <a:solidFill>
-                  <a:srgbClr val="0072BC"/>
+                  <a:srgbClr val="0A6CD6"/>
                 </a:solidFill>
                 <a:latin typeface="Aptos"/>
               </a:rPr>
@@ -9399,7 +9399,7 @@
             <a:r>
               <a:rPr sz="1800" b="1">
                 <a:solidFill>
-                  <a:srgbClr val="0F2F6B"/>
+                  <a:srgbClr val="1B4134"/>
                 </a:solidFill>
                 <a:latin typeface="Aptos"/>
               </a:rPr>
@@ -9434,7 +9434,7 @@
             <a:r>
               <a:rPr sz="1300" b="0">
                 <a:solidFill>
-                  <a:srgbClr val="4A5D78"/>
+                  <a:srgbClr val="4B5E57"/>
                 </a:solidFill>
                 <a:latin typeface="Aptos"/>
               </a:rPr>
@@ -9458,11 +9458,11 @@
             <a:avLst/>
           </a:prstGeom>
           <a:solidFill>
-            <a:srgbClr val="EEF3FA"/>
+            <a:srgbClr val="EFF5F1"/>
           </a:solidFill>
           <a:ln>
             <a:solidFill>
-              <a:srgbClr val="EEF3FA"/>
+              <a:srgbClr val="EFF5F1"/>
             </a:solidFill>
           </a:ln>
         </p:spPr>
@@ -9515,7 +9515,7 @@
             <a:r>
               <a:rPr sz="1300" b="1">
                 <a:solidFill>
-                  <a:srgbClr val="0072BC"/>
+                  <a:srgbClr val="0A6CD6"/>
                 </a:solidFill>
                 <a:latin typeface="Aptos"/>
               </a:rPr>
@@ -9550,7 +9550,7 @@
             <a:r>
               <a:rPr sz="1800" b="1">
                 <a:solidFill>
-                  <a:srgbClr val="0F2F6B"/>
+                  <a:srgbClr val="1B4134"/>
                 </a:solidFill>
                 <a:latin typeface="Aptos"/>
               </a:rPr>
@@ -9585,7 +9585,7 @@
             <a:r>
               <a:rPr sz="1300" b="0">
                 <a:solidFill>
-                  <a:srgbClr val="4A5D78"/>
+                  <a:srgbClr val="4B5E57"/>
                 </a:solidFill>
                 <a:latin typeface="Aptos"/>
               </a:rPr>
@@ -9609,11 +9609,11 @@
             <a:avLst/>
           </a:prstGeom>
           <a:solidFill>
-            <a:srgbClr val="EEF3FA"/>
+            <a:srgbClr val="EFF5F1"/>
           </a:solidFill>
           <a:ln>
             <a:solidFill>
-              <a:srgbClr val="EEF3FA"/>
+              <a:srgbClr val="EFF5F1"/>
             </a:solidFill>
           </a:ln>
         </p:spPr>
@@ -9666,7 +9666,7 @@
             <a:r>
               <a:rPr sz="1300" b="1">
                 <a:solidFill>
-                  <a:srgbClr val="0072BC"/>
+                  <a:srgbClr val="0A6CD6"/>
                 </a:solidFill>
                 <a:latin typeface="Aptos"/>
               </a:rPr>
@@ -9701,7 +9701,7 @@
             <a:r>
               <a:rPr sz="1800" b="1">
                 <a:solidFill>
-                  <a:srgbClr val="0F2F6B"/>
+                  <a:srgbClr val="1B4134"/>
                 </a:solidFill>
                 <a:latin typeface="Aptos"/>
               </a:rPr>
@@ -9736,7 +9736,7 @@
             <a:r>
               <a:rPr sz="1300" b="0">
                 <a:solidFill>
-                  <a:srgbClr val="4A5D78"/>
+                  <a:srgbClr val="4B5E57"/>
                 </a:solidFill>
                 <a:latin typeface="Aptos"/>
               </a:rPr>
@@ -9853,11 +9853,11 @@
             <a:avLst/>
           </a:prstGeom>
           <a:solidFill>
-            <a:srgbClr val="C9DCF2"/>
+            <a:srgbClr val="CFE3D6"/>
           </a:solidFill>
           <a:ln>
             <a:solidFill>
-              <a:srgbClr val="C9DCF2"/>
+              <a:srgbClr val="CFE3D6"/>
             </a:solidFill>
           </a:ln>
         </p:spPr>
@@ -9910,7 +9910,7 @@
             <a:r>
               <a:rPr sz="800" b="1">
                 <a:solidFill>
-                  <a:srgbClr val="4A5D78"/>
+                  <a:srgbClr val="4B5E57"/>
                 </a:solidFill>
                 <a:latin typeface="Aptos"/>
               </a:rPr>
@@ -9945,7 +9945,7 @@
             <a:r>
               <a:rPr sz="2800" b="1">
                 <a:solidFill>
-                  <a:srgbClr val="0F2F6B"/>
+                  <a:srgbClr val="1B4134"/>
                 </a:solidFill>
                 <a:latin typeface="Aptos"/>
               </a:rPr>
@@ -9969,11 +9969,11 @@
             <a:avLst/>
           </a:prstGeom>
           <a:solidFill>
-            <a:srgbClr val="0072BC"/>
+            <a:srgbClr val="0A6CD6"/>
           </a:solidFill>
           <a:ln>
             <a:solidFill>
-              <a:srgbClr val="0072BC"/>
+              <a:srgbClr val="0A6CD6"/>
             </a:solidFill>
           </a:ln>
         </p:spPr>
@@ -10026,7 +10026,7 @@
             <a:r>
               <a:rPr sz="1300" b="0">
                 <a:solidFill>
-                  <a:srgbClr val="4A5D78"/>
+                  <a:srgbClr val="4B5E57"/>
                 </a:solidFill>
                 <a:latin typeface="Aptos"/>
               </a:rPr>
@@ -10050,11 +10050,11 @@
             <a:avLst/>
           </a:prstGeom>
           <a:solidFill>
-            <a:srgbClr val="EEF3FA"/>
+            <a:srgbClr val="EFF5F1"/>
           </a:solidFill>
           <a:ln>
             <a:solidFill>
-              <a:srgbClr val="EEF3FA"/>
+              <a:srgbClr val="EFF5F1"/>
             </a:solidFill>
           </a:ln>
         </p:spPr>
@@ -10107,7 +10107,7 @@
             <a:r>
               <a:rPr sz="1400" b="1">
                 <a:solidFill>
-                  <a:srgbClr val="0072BC"/>
+                  <a:srgbClr val="0A6CD6"/>
                 </a:solidFill>
                 <a:latin typeface="Aptos"/>
               </a:rPr>
@@ -10142,7 +10142,7 @@
             <a:r>
               <a:rPr sz="1400" b="0">
                 <a:solidFill>
-                  <a:srgbClr val="0F2F6B"/>
+                  <a:srgbClr val="1B4134"/>
                 </a:solidFill>
                 <a:latin typeface="Aptos"/>
               </a:rPr>
@@ -10177,7 +10177,7 @@
             <a:r>
               <a:rPr sz="1400" b="1">
                 <a:solidFill>
-                  <a:srgbClr val="0072BC"/>
+                  <a:srgbClr val="0A6CD6"/>
                 </a:solidFill>
                 <a:latin typeface="Aptos"/>
               </a:rPr>
@@ -10212,7 +10212,7 @@
             <a:r>
               <a:rPr sz="1400" b="0">
                 <a:solidFill>
-                  <a:srgbClr val="0F2F6B"/>
+                  <a:srgbClr val="1B4134"/>
                 </a:solidFill>
                 <a:latin typeface="Aptos"/>
               </a:rPr>
@@ -10247,7 +10247,7 @@
             <a:r>
               <a:rPr sz="1400" b="1">
                 <a:solidFill>
-                  <a:srgbClr val="0072BC"/>
+                  <a:srgbClr val="0A6CD6"/>
                 </a:solidFill>
                 <a:latin typeface="Aptos"/>
               </a:rPr>
@@ -10282,7 +10282,7 @@
             <a:r>
               <a:rPr sz="1400" b="0">
                 <a:solidFill>
-                  <a:srgbClr val="0F2F6B"/>
+                  <a:srgbClr val="1B4134"/>
                 </a:solidFill>
                 <a:latin typeface="Aptos"/>
               </a:rPr>
@@ -10317,7 +10317,7 @@
             <a:r>
               <a:rPr sz="1400" b="1">
                 <a:solidFill>
-                  <a:srgbClr val="0072BC"/>
+                  <a:srgbClr val="0A6CD6"/>
                 </a:solidFill>
                 <a:latin typeface="Aptos"/>
               </a:rPr>
@@ -10352,7 +10352,7 @@
             <a:r>
               <a:rPr sz="1400" b="0">
                 <a:solidFill>
-                  <a:srgbClr val="0F2F6B"/>
+                  <a:srgbClr val="1B4134"/>
                 </a:solidFill>
                 <a:latin typeface="Aptos"/>
               </a:rPr>
@@ -10469,11 +10469,11 @@
             <a:avLst/>
           </a:prstGeom>
           <a:solidFill>
-            <a:srgbClr val="C9DCF2"/>
+            <a:srgbClr val="CFE3D6"/>
           </a:solidFill>
           <a:ln>
             <a:solidFill>
-              <a:srgbClr val="C9DCF2"/>
+              <a:srgbClr val="CFE3D6"/>
             </a:solidFill>
           </a:ln>
         </p:spPr>
@@ -10526,7 +10526,7 @@
             <a:r>
               <a:rPr sz="800" b="1">
                 <a:solidFill>
-                  <a:srgbClr val="4A5D78"/>
+                  <a:srgbClr val="4B5E57"/>
                 </a:solidFill>
                 <a:latin typeface="Aptos"/>
               </a:rPr>
@@ -10561,7 +10561,7 @@
             <a:r>
               <a:rPr sz="2800" b="1">
                 <a:solidFill>
-                  <a:srgbClr val="0F2F6B"/>
+                  <a:srgbClr val="1B4134"/>
                 </a:solidFill>
                 <a:latin typeface="Aptos"/>
               </a:rPr>
@@ -10585,11 +10585,11 @@
             <a:avLst/>
           </a:prstGeom>
           <a:solidFill>
-            <a:srgbClr val="0072BC"/>
+            <a:srgbClr val="0A6CD6"/>
           </a:solidFill>
           <a:ln>
             <a:solidFill>
-              <a:srgbClr val="0072BC"/>
+              <a:srgbClr val="0A6CD6"/>
             </a:solidFill>
           </a:ln>
         </p:spPr>
@@ -10642,7 +10642,7 @@
             <a:r>
               <a:rPr sz="1300" b="0">
                 <a:solidFill>
-                  <a:srgbClr val="4A5D78"/>
+                  <a:srgbClr val="4B5E57"/>
                 </a:solidFill>
                 <a:latin typeface="Aptos"/>
               </a:rPr>
@@ -10666,11 +10666,11 @@
             <a:avLst/>
           </a:prstGeom>
           <a:solidFill>
-            <a:srgbClr val="E1EDF9"/>
+            <a:srgbClr val="EAF3FC"/>
           </a:solidFill>
           <a:ln>
             <a:solidFill>
-              <a:srgbClr val="E1EDF9"/>
+              <a:srgbClr val="EAF3FC"/>
             </a:solidFill>
           </a:ln>
         </p:spPr>
@@ -10723,7 +10723,7 @@
             <a:r>
               <a:rPr sz="1300" b="1">
                 <a:solidFill>
-                  <a:srgbClr val="0072BC"/>
+                  <a:srgbClr val="0A6CD6"/>
                 </a:solidFill>
                 <a:latin typeface="Aptos"/>
               </a:rPr>
@@ -10747,11 +10747,11 @@
             <a:avLst/>
           </a:prstGeom>
           <a:solidFill>
-            <a:srgbClr val="EEF3FA"/>
+            <a:srgbClr val="EFF5F1"/>
           </a:solidFill>
           <a:ln>
             <a:solidFill>
-              <a:srgbClr val="EEF3FA"/>
+              <a:srgbClr val="EFF5F1"/>
             </a:solidFill>
           </a:ln>
         </p:spPr>
@@ -10804,7 +10804,7 @@
             <a:r>
               <a:rPr sz="1400" b="1">
                 <a:solidFill>
-                  <a:srgbClr val="0F2F6B"/>
+                  <a:srgbClr val="1B4134"/>
                 </a:solidFill>
                 <a:latin typeface="Aptos"/>
               </a:rPr>
@@ -10828,11 +10828,11 @@
             <a:avLst/>
           </a:prstGeom>
           <a:solidFill>
-            <a:srgbClr val="EEF3FA"/>
+            <a:srgbClr val="EFF5F1"/>
           </a:solidFill>
           <a:ln>
             <a:solidFill>
-              <a:srgbClr val="EEF3FA"/>
+              <a:srgbClr val="EFF5F1"/>
             </a:solidFill>
           </a:ln>
         </p:spPr>
@@ -10885,7 +10885,7 @@
             <a:r>
               <a:rPr sz="1400" b="1">
                 <a:solidFill>
-                  <a:srgbClr val="0F2F6B"/>
+                  <a:srgbClr val="1B4134"/>
                 </a:solidFill>
                 <a:latin typeface="Aptos"/>
               </a:rPr>
@@ -10909,11 +10909,11 @@
             <a:avLst/>
           </a:prstGeom>
           <a:solidFill>
-            <a:srgbClr val="EEF3FA"/>
+            <a:srgbClr val="EFF5F1"/>
           </a:solidFill>
           <a:ln>
             <a:solidFill>
-              <a:srgbClr val="EEF3FA"/>
+              <a:srgbClr val="EFF5F1"/>
             </a:solidFill>
           </a:ln>
         </p:spPr>
@@ -10966,7 +10966,7 @@
             <a:r>
               <a:rPr sz="1400" b="1">
                 <a:solidFill>
-                  <a:srgbClr val="0F2F6B"/>
+                  <a:srgbClr val="1B4134"/>
                 </a:solidFill>
                 <a:latin typeface="Aptos"/>
               </a:rPr>
@@ -10990,11 +10990,11 @@
             <a:avLst/>
           </a:prstGeom>
           <a:solidFill>
-            <a:srgbClr val="EEF3FA"/>
+            <a:srgbClr val="EFF5F1"/>
           </a:solidFill>
           <a:ln>
             <a:solidFill>
-              <a:srgbClr val="EEF3FA"/>
+              <a:srgbClr val="EFF5F1"/>
             </a:solidFill>
           </a:ln>
         </p:spPr>
@@ -11047,7 +11047,7 @@
             <a:r>
               <a:rPr sz="1400" b="1">
                 <a:solidFill>
-                  <a:srgbClr val="0F2F6B"/>
+                  <a:srgbClr val="1B4134"/>
                 </a:solidFill>
                 <a:latin typeface="Aptos"/>
               </a:rPr>
@@ -11071,11 +11071,11 @@
             <a:avLst/>
           </a:prstGeom>
           <a:solidFill>
-            <a:srgbClr val="EEF3FA"/>
+            <a:srgbClr val="EFF5F1"/>
           </a:solidFill>
           <a:ln>
             <a:solidFill>
-              <a:srgbClr val="EEF3FA"/>
+              <a:srgbClr val="EFF5F1"/>
             </a:solidFill>
           </a:ln>
         </p:spPr>
@@ -11128,7 +11128,7 @@
             <a:r>
               <a:rPr sz="1400" b="1">
                 <a:solidFill>
-                  <a:srgbClr val="0F2F6B"/>
+                  <a:srgbClr val="1B4134"/>
                 </a:solidFill>
                 <a:latin typeface="Aptos"/>
               </a:rPr>
@@ -11152,11 +11152,11 @@
             <a:avLst/>
           </a:prstGeom>
           <a:solidFill>
-            <a:srgbClr val="EEF3FA"/>
+            <a:srgbClr val="EFF5F1"/>
           </a:solidFill>
           <a:ln>
             <a:solidFill>
-              <a:srgbClr val="EEF3FA"/>
+              <a:srgbClr val="EFF5F1"/>
             </a:solidFill>
           </a:ln>
         </p:spPr>
@@ -11209,7 +11209,7 @@
             <a:r>
               <a:rPr sz="1400" b="1">
                 <a:solidFill>
-                  <a:srgbClr val="0F2F6B"/>
+                  <a:srgbClr val="1B4134"/>
                 </a:solidFill>
                 <a:latin typeface="Aptos"/>
               </a:rPr>
@@ -11244,7 +11244,7 @@
             <a:r>
               <a:rPr sz="1200" b="1">
                 <a:solidFill>
-                  <a:srgbClr val="0072BC"/>
+                  <a:srgbClr val="0A6CD6"/>
                 </a:solidFill>
                 <a:latin typeface="Aptos"/>
               </a:rPr>
@@ -11279,7 +11279,7 @@
             <a:r>
               <a:rPr sz="1400" b="0">
                 <a:solidFill>
-                  <a:srgbClr val="0F2F6B"/>
+                  <a:srgbClr val="1B4134"/>
                 </a:solidFill>
                 <a:latin typeface="Aptos"/>
               </a:rPr>

</xml_diff>